<commit_message>
Update figures to mid-2026; add agenda, disclaimers, speaker notes
- Revenue numbers refreshed (Nvidia ~$300B run-rate, OpenAI ~$33B,
  Anthropic ~$45B gross / ~$22B net, LangChain ~$16M) in README + slides
- slides.md: add Agenda slide, ILLUSTRATIVE tags on all CEO-math slides,
  per-slide presenter notes; re-rendered PDF/PPTX

Co-Authored-By: Claude Opus 4.8 (1M context) <noreply@anthropic.com>
</commit_message>
<xml_diff>
--- a/slides.pptx
+++ b/slides.pptx
@@ -25,9 +25,10 @@
     <p:sldId id="273" r:id="rId19"/>
     <p:sldId id="274" r:id="rId20"/>
     <p:sldId id="275" r:id="rId21"/>
+    <p:sldId id="276" r:id="rId22"/>
   </p:sldIdLst>
   <p:notesMasterIdLst>
-    <p:notesMasterId r:id="rId22"/>
+    <p:notesMasterId r:id="rId23"/>
   </p:notesMasterIdLst>
   <p:sldSz cx="12192000" cy="6858000"/>
   <p:notesSz cx="6858000" cy="12192000"/>
@@ -521,7 +522,9 @@
           <a:p>
             <a:r>
               <a:rPr lang="en-US" dirty="0"/>
-              <a:t/>
+              <a:t>Open: a model is just one piece. Today we map the whole stack, then look at the
+money and what it means for DevOps. Figures are as of mid-2026; the CEO-math
+numbers are illustrative — the method matters, not the exact dollars.</a:t>
             </a:r>
             <a:endParaRPr lang="en-US" dirty="0"/>
           </a:p>
@@ -609,7 +612,8 @@
           <a:p>
             <a:r>
               <a:rPr lang="en-US" dirty="0"/>
-              <a:t/>
+              <a:t>Shift gears. Students entering AI need orientation: where dollars flow today vs
+where value is created. These are two different questions.</a:t>
             </a:r>
             <a:endParaRPr lang="en-US" dirty="0"/>
           </a:p>
@@ -697,7 +701,9 @@
           <a:p>
             <a:r>
               <a:rPr lang="en-US" dirty="0"/>
-              <a:t/>
+              <a:t>Figures mid-2026. *Anthropic ~$45B is gross (books cloud-reseller spend);
+~$22B net — always ask gross or net. Anthropic just passed OpenAI. Punchline:
+the most-talked-about layer earns the least.</a:t>
             </a:r>
             <a:endParaRPr lang="en-US" dirty="0"/>
           </a:p>
@@ -785,7 +791,9 @@
           <a:p>
             <a:r>
               <a:rPr lang="en-US" dirty="0"/>
-              <a:t/>
+              <a:t>Ask the room: "Copilot — which type?" Efficiency. "ChatGPT launch?"
+Market-creating. Same LLM, different use → different type. AI coding = efficiency
+= cost-cutting, which sets up the math.</a:t>
             </a:r>
             <a:endParaRPr lang="en-US" dirty="0"/>
           </a:p>
@@ -873,7 +881,9 @@
           <a:p>
             <a:r>
               <a:rPr lang="en-US" dirty="0"/>
-              <a:t/>
+              <a:t>Say out loud: these dollar numbers are illustrative, not Klarna's books. The
+$0.99/resolution is Intercom Fin's real public price. The Klarna rehire is the
+honest part — don't sell AI as headcount-zero.</a:t>
             </a:r>
             <a:endParaRPr lang="en-US" dirty="0"/>
           </a:p>
@@ -961,7 +971,8 @@
           <a:p>
             <a:r>
               <a:rPr lang="en-US" dirty="0"/>
-              <a:t/>
+              <a:t>This is layer 3 (data/RAG) in production. Value here is time saved + better
+answers, not a flashy chatbot. Real, measured adoption (98%).</a:t>
             </a:r>
             <a:endParaRPr lang="en-US" dirty="0"/>
           </a:p>
@@ -1049,7 +1060,9 @@
           <a:p>
             <a:r>
               <a:rPr lang="en-US" dirty="0"/>
-              <a:t/>
+              <a:t>This resolves the apparent contradiction: pyramid says app layer is thin, but
+case studies show huge value. Two different questions. Most students in this
+room will be operators, not AI vendors — the value is on their side.</a:t>
             </a:r>
             <a:endParaRPr lang="en-US" dirty="0"/>
           </a:p>
@@ -1137,7 +1150,8 @@
           <a:p>
             <a:r>
               <a:rPr lang="en-US" dirty="0"/>
-              <a:t/>
+              <a:t>Now the part most relevant to this class. Three beats: coding assistant, AIOps,
+and the DORA reality check.</a:t>
             </a:r>
             <a:endParaRPr lang="en-US" dirty="0"/>
           </a:p>
@@ -1225,7 +1239,9 @@
           <a:p>
             <a:r>
               <a:rPr lang="en-US" dirty="0"/>
-              <a:t/>
+              <a:t>"30% of dev time is coding" is an assumption — defend it: the rest is meetings,
+review, debugging, design. The real lesson: efficiency value is only real if you
+defer hires or ship more. Otherwise it's paper.</a:t>
             </a:r>
             <a:endParaRPr lang="en-US" dirty="0"/>
           </a:p>
@@ -1313,7 +1329,9 @@
           <a:p>
             <a:r>
               <a:rPr lang="en-US" dirty="0"/>
-              <a:t/>
+              <a:t>This is the slide where I correct the naive pitch. Vendors quote only the
+savings. Make them net out license + tokens + setup + maintenance. Downtime
+avoided is usually the biggest line — but hardest to estimate honestly.</a:t>
             </a:r>
             <a:endParaRPr lang="en-US" dirty="0"/>
           </a:p>
@@ -1401,7 +1419,9 @@
           <a:p>
             <a:r>
               <a:rPr lang="en-US" dirty="0"/>
-              <a:t/>
+              <a:t>The most important slide for this audience. AI is not a silver bullet. Your job
+— pipelines, testing, small batches — matters MORE in the AI era, not less. End
+the DevOps section on this.</a:t>
             </a:r>
             <a:endParaRPr lang="en-US" dirty="0"/>
           </a:p>
@@ -1489,7 +1509,8 @@
           <a:p>
             <a:r>
               <a:rPr lang="en-US" dirty="0"/>
-              <a:t/>
+              <a:t>~35-45 min. Stop me with questions during the layers; hold strategy questions
+for the business section where they'll be answered.</a:t>
             </a:r>
             <a:endParaRPr lang="en-US" dirty="0"/>
           </a:p>
@@ -1577,7 +1598,8 @@
           <a:p>
             <a:r>
               <a:rPr lang="en-US" dirty="0"/>
-              <a:t/>
+              <a:t>Recap in 30 seconds, then open Q&amp;A. If short on time, slides 5 (layers),
+pyramid, and DORA are the must-keeps.</a:t>
             </a:r>
             <a:endParaRPr lang="en-US" dirty="0"/>
           </a:p>
@@ -1619,6 +1641,96 @@
 </p:notes>
 </file>
 
+<file path=ppt/notesSlides/notesSlide21.xml><?xml version="1.0" encoding="utf-8"?>
+<p:notes xmlns:a="http://schemas.openxmlformats.org/drawingml/2006/main" xmlns:r="http://schemas.openxmlformats.org/officeDocument/2006/relationships" xmlns:p="http://schemas.openxmlformats.org/presentationml/2006/main">
+  <p:cSld>
+    <p:spTree>
+      <p:nvGrpSpPr>
+        <p:cNvPr id="1" name=""/>
+        <p:cNvGrpSpPr/>
+        <p:nvPr/>
+      </p:nvGrpSpPr>
+      <p:grpSpPr>
+        <a:xfrm>
+          <a:off x="0" y="0"/>
+          <a:ext cx="0" cy="0"/>
+          <a:chOff x="0" y="0"/>
+          <a:chExt cx="0" cy="0"/>
+        </a:xfrm>
+      </p:grpSpPr>
+      <p:sp>
+        <p:nvSpPr>
+          <p:cNvPr id="2" name="Slide Image Placeholder 1"/>
+          <p:cNvSpPr>
+            <a:spLocks noGrp="1" noRot="1" noChangeAspect="1"/>
+          </p:cNvSpPr>
+          <p:nvPr>
+            <p:ph type="sldImg"/>
+          </p:nvPr>
+        </p:nvSpPr>
+        <p:spPr/>
+      </p:sp>
+      <p:sp>
+        <p:nvSpPr>
+          <p:cNvPr id="3" name="Notes Placeholder 2"/>
+          <p:cNvSpPr>
+            <a:spLocks noGrp="1"/>
+          </p:cNvSpPr>
+          <p:nvPr>
+            <p:ph type="body" idx="1"/>
+          </p:nvPr>
+        </p:nvSpPr>
+        <p:spPr/>
+        <p:txBody>
+          <a:bodyPr/>
+          <a:lstStyle/>
+          <a:p>
+            <a:r>
+              <a:rPr lang="en-US" dirty="0"/>
+              <a:t>Likely questions: "should we train our own model?" (no — use/fine-tune/RAG);
+"will AI replace devs?" (Klarna rehired; DORA shows fundamentals win);
+"gross vs net revenue?" (Anthropic example).</a:t>
+            </a:r>
+            <a:endParaRPr lang="en-US" dirty="0"/>
+          </a:p>
+        </p:txBody>
+      </p:sp>
+      <p:sp>
+        <p:nvSpPr>
+          <p:cNvPr id="4" name="Slide Number Placeholder 3"/>
+          <p:cNvSpPr>
+            <a:spLocks noGrp="1"/>
+          </p:cNvSpPr>
+          <p:nvPr>
+            <p:ph type="sldNum" sz="quarter" idx="10"/>
+          </p:nvPr>
+        </p:nvSpPr>
+        <p:spPr/>
+        <p:txBody>
+          <a:bodyPr/>
+          <a:lstStyle/>
+          <a:p>
+            <a:fld id="{F7021451-1387-4CA6-816F-3879F97B5CBC}" type="slidenum">
+              <a:rPr lang="en-US"/>
+              <a:t>21</a:t>
+            </a:fld>
+            <a:endParaRPr lang="en-US"/>
+          </a:p>
+        </p:txBody>
+      </p:sp>
+    </p:spTree>
+    <p:extLst>
+      <p:ext uri="{BB962C8B-B14F-4D97-AF65-F5344CB8AC3E}">
+        <p14:creationId xmlns:p14="http://schemas.microsoft.com/office/powerpoint/2010/main" val="1024086991"/>
+      </p:ext>
+    </p:extLst>
+  </p:cSld>
+  <p:clrMapOvr>
+    <a:masterClrMapping/>
+  </p:clrMapOvr>
+</p:notes>
+</file>
+
 <file path=ppt/notesSlides/notesSlide3.xml><?xml version="1.0" encoding="utf-8"?>
 <p:notes xmlns:a="http://schemas.openxmlformats.org/drawingml/2006/main" xmlns:r="http://schemas.openxmlformats.org/officeDocument/2006/relationships" xmlns:p="http://schemas.openxmlformats.org/presentationml/2006/main">
   <p:cSld>
@@ -1665,7 +1777,9 @@
           <a:p>
             <a:r>
               <a:rPr lang="en-US" dirty="0"/>
-              <a:t/>
+              <a:t>Concrete example: a research assistant for new scientific papers. The model
+alone can't help — it has a knowledge cutoff, needs GPUs, needs the papers as
+data, needs steps to plan/summarize, and a UI. That's the whole stack.</a:t>
             </a:r>
             <a:endParaRPr lang="en-US" dirty="0"/>
           </a:p>
@@ -1753,7 +1867,8 @@
           <a:p>
             <a:r>
               <a:rPr lang="en-US" dirty="0"/>
-              <a:t/>
+              <a:t>You can buy a managed service that hides several layers, or build each yourself.
+Either way you should know all five exist — that's how you debug cost/quality.</a:t>
             </a:r>
             <a:endParaRPr lang="en-US" dirty="0"/>
           </a:p>
@@ -1841,7 +1956,8 @@
           <a:p>
             <a:r>
               <a:rPr lang="en-US" dirty="0"/>
-              <a:t/>
+              <a:t>DevOps tie-in: this is the layer your audience provisions — GPU nodes on k8s,
+autoscaling, cost control. The capex here is what feeds the revenue pyramid later.</a:t>
             </a:r>
             <a:endParaRPr lang="en-US" dirty="0"/>
           </a:p>
@@ -1929,7 +2045,9 @@
           <a:p>
             <a:r>
               <a:rPr lang="en-US" dirty="0"/>
-              <a:t/>
+              <a:t>Common student misconception: "we must train our own model." Almost never. Use
+an existing one; fine-tune for behavior/format; RAG for knowledge. MLOps is the
+DevOps of this layer.</a:t>
             </a:r>
             <a:endParaRPr lang="en-US" dirty="0"/>
           </a:p>
@@ -2017,7 +2135,8 @@
           <a:p>
             <a:r>
               <a:rPr lang="en-US" dirty="0"/>
-              <a:t/>
+              <a:t>RAG = open-book exam vs memorizing. The model looks things up at answer time.
+This is what powers the Morgan Stanley case later.</a:t>
             </a:r>
             <a:endParaRPr lang="en-US" dirty="0"/>
           </a:p>
@@ -2105,7 +2224,9 @@
           <a:p>
             <a:r>
               <a:rPr lang="en-US" dirty="0"/>
-              <a:t/>
+              <a:t>Key line: orchestration is the mechanism, "agentic" is the behavior. This is the
+most hyped layer — remember that when we hit the revenue pyramid (it earns the
+least).</a:t>
             </a:r>
             <a:endParaRPr lang="en-US" dirty="0"/>
           </a:p>
@@ -2193,7 +2314,8 @@
           <a:p>
             <a:r>
               <a:rPr lang="en-US" dirty="0"/>
-              <a:t/>
+              <a:t>Examples: summarize email, text→report, chat replacing a shopping/fintech form.
+The brain is layer 4; fitting it into screens + business flow is layer 5.</a:t>
             </a:r>
             <a:endParaRPr lang="en-US" dirty="0"/>
           </a:p>
@@ -3013,6 +3135,45 @@
 <file path=ppt/slides/slide20.xml><?xml version="1.0" encoding="utf-8"?>
 <p:sld xmlns:a="http://schemas.openxmlformats.org/drawingml/2006/main" xmlns:r="http://schemas.openxmlformats.org/officeDocument/2006/relationships" xmlns:p="http://schemas.openxmlformats.org/presentationml/2006/main">
   <p:cSld name="Slide 20">
+    <p:bg>
+      <p:bgPr>
+        <a:blipFill dpi="0" rotWithShape="1">
+          <a:blip r:embed="rId1">
+            <a:lum/>
+          </a:blip>
+          <a:srcRect/>
+          <a:stretch>
+            <a:fillRect/>
+          </a:stretch>
+        </a:blipFill>
+        <a:effectLst/>
+      </p:bgPr>
+    </p:bg>
+    <p:spTree>
+      <p:nvGrpSpPr>
+        <p:cNvPr id="1" name=""/>
+        <p:cNvGrpSpPr/>
+        <p:nvPr/>
+      </p:nvGrpSpPr>
+      <p:grpSpPr>
+        <a:xfrm>
+          <a:off x="0" y="0"/>
+          <a:ext cx="0" cy="0"/>
+          <a:chOff x="0" y="0"/>
+          <a:chExt cx="0" cy="0"/>
+        </a:xfrm>
+      </p:grpSpPr>
+    </p:spTree>
+  </p:cSld>
+  <p:clrMapOvr>
+    <a:masterClrMapping/>
+  </p:clrMapOvr>
+</p:sld>
+</file>
+
+<file path=ppt/slides/slide21.xml><?xml version="1.0" encoding="utf-8"?>
+<p:sld xmlns:a="http://schemas.openxmlformats.org/drawingml/2006/main" xmlns:r="http://schemas.openxmlformats.org/officeDocument/2006/relationships" xmlns:p="http://schemas.openxmlformats.org/presentationml/2006/main">
+  <p:cSld name="Slide 21">
     <p:bg>
       <p:bgPr>
         <a:blipFill dpi="0" rotWithShape="1">

</xml_diff>

<commit_message>
Refocus DevOps section on GenAI for SRE (drop coding assistant)
Coding assistants are dev productivity, not SRE/platform. Rebuild the
section around the GenAI-for-SRE job description:
- AI-SRE agent as a capstone that exercises all 5 layers
- Incident triage / RCA / remediation (Cleric, Resolve.ai, Traversal,
  Rootly, incident.io, Datadog Bits AI; Traversal@AmEx 82% RCA / -32% MTTR;
  Microsoft RCACopilot ~0.77)
- Observability + NL querying (Datadog Bits, Grafana, Toto)
- RAG over telemetry/incident history (FAISS/Weaviate)
- CI/CD risk & guardrails (frontier)
- Economics net of AI cost + DORA 2024 counterpoint

Updates slides.md and docs/devops-cases.md; re-rendered PDF/PPTX.

Co-Authored-By: Claude Opus 4.8 (1M context) <noreply@anthropic.com>
</commit_message>
<xml_diff>
--- a/slides.pptx
+++ b/slides.pptx
@@ -26,9 +26,12 @@
     <p:sldId id="274" r:id="rId20"/>
     <p:sldId id="275" r:id="rId21"/>
     <p:sldId id="276" r:id="rId22"/>
+    <p:sldId id="277" r:id="rId23"/>
+    <p:sldId id="278" r:id="rId24"/>
+    <p:sldId id="279" r:id="rId25"/>
   </p:sldIdLst>
   <p:notesMasterIdLst>
-    <p:notesMasterId r:id="rId23"/>
+    <p:notesMasterId r:id="rId26"/>
   </p:notesMasterIdLst>
   <p:sldSz cx="12192000" cy="6858000"/>
   <p:notesSz cx="6858000" cy="12192000"/>
@@ -1150,8 +1153,9 @@
           <a:p>
             <a:r>
               <a:rPr lang="en-US" dirty="0"/>
-              <a:t>Now the part most relevant to this class. Three beats: coding assistant, AIOps,
-and the DORA reality check.</a:t>
+              <a:t>Reframe: coding assistants help app devs, not platform/SRE. This section is the
+GenAI-for-SRE job: triage, RCA, runbooks, observability, CI/CD risk. And it's
+the capstone — it uses every layer we just covered.</a:t>
             </a:r>
             <a:endParaRPr lang="en-US" dirty="0"/>
           </a:p>
@@ -1239,9 +1243,10 @@
           <a:p>
             <a:r>
               <a:rPr lang="en-US" dirty="0"/>
-              <a:t>"30% of dev time is coding" is an assumption — defend it: the rest is meetings,
-review, debugging, design. The real lesson: efficiency value is only real if you
-defer hires or ship more. Otherwise it's paper.</a:t>
+              <a:t>Payoff slide. Tie the whole lecture together. Walk bottom-up: the agent runs on
+GPUs, uses an LLM, grounds on a vector DB of your telemetry + past incidents +
+runbooks (RAG), orchestrates multi-step investigation, and meets the on-call
+engineer in Slack. Map each to the JD they'll be hiring against.</a:t>
             </a:r>
             <a:endParaRPr lang="en-US" dirty="0"/>
           </a:p>
@@ -1329,9 +1334,9 @@
           <a:p>
             <a:r>
               <a:rPr lang="en-US" dirty="0"/>
-              <a:t>This is the slide where I correct the naive pitch. Vendors quote only the
-savings. Make them net out license + tokens + setup + maintenance. Downtime
-avoided is usually the biggest line — but hardest to estimate honestly.</a:t>
+              <a:t>Area 1+2 of the JD. Stress: the credible numbers come with a named customer or a
+published study; treat vendor ranges skeptically. Self-healing exists but humans
+approve production actions.</a:t>
             </a:r>
             <a:endParaRPr lang="en-US" dirty="0"/>
           </a:p>
@@ -1374,6 +1379,365 @@
 </file>
 
 <file path=ppt/notesSlides/notesSlide19.xml><?xml version="1.0" encoding="utf-8"?>
+<p:notes xmlns:a="http://schemas.openxmlformats.org/drawingml/2006/main" xmlns:r="http://schemas.openxmlformats.org/officeDocument/2006/relationships" xmlns:p="http://schemas.openxmlformats.org/presentationml/2006/main">
+  <p:cSld>
+    <p:spTree>
+      <p:nvGrpSpPr>
+        <p:cNvPr id="1" name=""/>
+        <p:cNvGrpSpPr/>
+        <p:nvPr/>
+      </p:nvGrpSpPr>
+      <p:grpSpPr>
+        <a:xfrm>
+          <a:off x="0" y="0"/>
+          <a:ext cx="0" cy="0"/>
+          <a:chOff x="0" y="0"/>
+          <a:chExt cx="0" cy="0"/>
+        </a:xfrm>
+      </p:grpSpPr>
+      <p:sp>
+        <p:nvSpPr>
+          <p:cNvPr id="2" name="Slide Image Placeholder 1"/>
+          <p:cNvSpPr>
+            <a:spLocks noGrp="1" noRot="1" noChangeAspect="1"/>
+          </p:cNvSpPr>
+          <p:nvPr>
+            <p:ph type="sldImg"/>
+          </p:nvPr>
+        </p:nvSpPr>
+        <p:spPr/>
+      </p:sp>
+      <p:sp>
+        <p:nvSpPr>
+          <p:cNvPr id="3" name="Notes Placeholder 2"/>
+          <p:cNvSpPr>
+            <a:spLocks noGrp="1"/>
+          </p:cNvSpPr>
+          <p:nvPr>
+            <p:ph type="body" idx="1"/>
+          </p:nvPr>
+        </p:nvSpPr>
+        <p:spPr/>
+        <p:txBody>
+          <a:bodyPr/>
+          <a:lstStyle/>
+          <a:p>
+            <a:r>
+              <a:rPr lang="en-US" dirty="0"/>
+              <a:t>Areas 2+3 of the JD. The big shift: SLI/SLO and platform health become
+queryable in natural language. The vector DB of incident history is the
+"institutional memory" — this is layer 3 doing real work in SRE.</a:t>
+            </a:r>
+            <a:endParaRPr lang="en-US" dirty="0"/>
+          </a:p>
+        </p:txBody>
+      </p:sp>
+      <p:sp>
+        <p:nvSpPr>
+          <p:cNvPr id="4" name="Slide Number Placeholder 3"/>
+          <p:cNvSpPr>
+            <a:spLocks noGrp="1"/>
+          </p:cNvSpPr>
+          <p:nvPr>
+            <p:ph type="sldNum" sz="quarter" idx="10"/>
+          </p:nvPr>
+        </p:nvSpPr>
+        <p:spPr/>
+        <p:txBody>
+          <a:bodyPr/>
+          <a:lstStyle/>
+          <a:p>
+            <a:fld id="{F7021451-1387-4CA6-816F-3879F97B5CBC}" type="slidenum">
+              <a:rPr lang="en-US"/>
+              <a:t>19</a:t>
+            </a:fld>
+            <a:endParaRPr lang="en-US"/>
+          </a:p>
+        </p:txBody>
+      </p:sp>
+    </p:spTree>
+    <p:extLst>
+      <p:ext uri="{BB962C8B-B14F-4D97-AF65-F5344CB8AC3E}">
+        <p14:creationId xmlns:p14="http://schemas.microsoft.com/office/powerpoint/2010/main" val="1024086991"/>
+      </p:ext>
+    </p:extLst>
+  </p:cSld>
+  <p:clrMapOvr>
+    <a:masterClrMapping/>
+  </p:clrMapOvr>
+</p:notes>
+</file>
+
+<file path=ppt/notesSlides/notesSlide2.xml><?xml version="1.0" encoding="utf-8"?>
+<p:notes xmlns:a="http://schemas.openxmlformats.org/drawingml/2006/main" xmlns:r="http://schemas.openxmlformats.org/officeDocument/2006/relationships" xmlns:p="http://schemas.openxmlformats.org/presentationml/2006/main">
+  <p:cSld>
+    <p:spTree>
+      <p:nvGrpSpPr>
+        <p:cNvPr id="1" name=""/>
+        <p:cNvGrpSpPr/>
+        <p:nvPr/>
+      </p:nvGrpSpPr>
+      <p:grpSpPr>
+        <a:xfrm>
+          <a:off x="0" y="0"/>
+          <a:ext cx="0" cy="0"/>
+          <a:chOff x="0" y="0"/>
+          <a:chExt cx="0" cy="0"/>
+        </a:xfrm>
+      </p:grpSpPr>
+      <p:sp>
+        <p:nvSpPr>
+          <p:cNvPr id="2" name="Slide Image Placeholder 1"/>
+          <p:cNvSpPr>
+            <a:spLocks noGrp="1" noRot="1" noChangeAspect="1"/>
+          </p:cNvSpPr>
+          <p:nvPr>
+            <p:ph type="sldImg"/>
+          </p:nvPr>
+        </p:nvSpPr>
+        <p:spPr/>
+      </p:sp>
+      <p:sp>
+        <p:nvSpPr>
+          <p:cNvPr id="3" name="Notes Placeholder 2"/>
+          <p:cNvSpPr>
+            <a:spLocks noGrp="1"/>
+          </p:cNvSpPr>
+          <p:nvPr>
+            <p:ph type="body" idx="1"/>
+          </p:nvPr>
+        </p:nvSpPr>
+        <p:spPr/>
+        <p:txBody>
+          <a:bodyPr/>
+          <a:lstStyle/>
+          <a:p>
+            <a:r>
+              <a:rPr lang="en-US" dirty="0"/>
+              <a:t>~35-45 min. Stop me with questions during the layers; hold strategy questions
+for the business section where they'll be answered.</a:t>
+            </a:r>
+            <a:endParaRPr lang="en-US" dirty="0"/>
+          </a:p>
+        </p:txBody>
+      </p:sp>
+      <p:sp>
+        <p:nvSpPr>
+          <p:cNvPr id="4" name="Slide Number Placeholder 3"/>
+          <p:cNvSpPr>
+            <a:spLocks noGrp="1"/>
+          </p:cNvSpPr>
+          <p:nvPr>
+            <p:ph type="sldNum" sz="quarter" idx="10"/>
+          </p:nvPr>
+        </p:nvSpPr>
+        <p:spPr/>
+        <p:txBody>
+          <a:bodyPr/>
+          <a:lstStyle/>
+          <a:p>
+            <a:fld id="{F7021451-1387-4CA6-816F-3879F97B5CBC}" type="slidenum">
+              <a:rPr lang="en-US"/>
+              <a:t>2</a:t>
+            </a:fld>
+            <a:endParaRPr lang="en-US"/>
+          </a:p>
+        </p:txBody>
+      </p:sp>
+    </p:spTree>
+    <p:extLst>
+      <p:ext uri="{BB962C8B-B14F-4D97-AF65-F5344CB8AC3E}">
+        <p14:creationId xmlns:p14="http://schemas.microsoft.com/office/powerpoint/2010/main" val="1024086991"/>
+      </p:ext>
+    </p:extLst>
+  </p:cSld>
+  <p:clrMapOvr>
+    <a:masterClrMapping/>
+  </p:clrMapOvr>
+</p:notes>
+</file>
+
+<file path=ppt/notesSlides/notesSlide20.xml><?xml version="1.0" encoding="utf-8"?>
+<p:notes xmlns:a="http://schemas.openxmlformats.org/drawingml/2006/main" xmlns:r="http://schemas.openxmlformats.org/officeDocument/2006/relationships" xmlns:p="http://schemas.openxmlformats.org/presentationml/2006/main">
+  <p:cSld>
+    <p:spTree>
+      <p:nvGrpSpPr>
+        <p:cNvPr id="1" name=""/>
+        <p:cNvGrpSpPr/>
+        <p:nvPr/>
+      </p:nvGrpSpPr>
+      <p:grpSpPr>
+        <a:xfrm>
+          <a:off x="0" y="0"/>
+          <a:ext cx="0" cy="0"/>
+          <a:chOff x="0" y="0"/>
+          <a:chExt cx="0" cy="0"/>
+        </a:xfrm>
+      </p:grpSpPr>
+      <p:sp>
+        <p:nvSpPr>
+          <p:cNvPr id="2" name="Slide Image Placeholder 1"/>
+          <p:cNvSpPr>
+            <a:spLocks noGrp="1" noRot="1" noChangeAspect="1"/>
+          </p:cNvSpPr>
+          <p:nvPr>
+            <p:ph type="sldImg"/>
+          </p:nvPr>
+        </p:nvSpPr>
+        <p:spPr/>
+      </p:sp>
+      <p:sp>
+        <p:nvSpPr>
+          <p:cNvPr id="3" name="Notes Placeholder 2"/>
+          <p:cNvSpPr>
+            <a:spLocks noGrp="1"/>
+          </p:cNvSpPr>
+          <p:nvPr>
+            <p:ph type="body" idx="1"/>
+          </p:nvPr>
+        </p:nvSpPr>
+        <p:spPr/>
+        <p:txBody>
+          <a:bodyPr/>
+          <a:lstStyle/>
+          <a:p>
+            <a:r>
+              <a:rPr lang="en-US" dirty="0"/>
+              <a:t>Area 4 of the JD. Be candid: this is greenfield. Great project territory for
+students. Naturally leads into DORA — speed at the deploy gate without
+discipline is dangerous.</a:t>
+            </a:r>
+            <a:endParaRPr lang="en-US" dirty="0"/>
+          </a:p>
+        </p:txBody>
+      </p:sp>
+      <p:sp>
+        <p:nvSpPr>
+          <p:cNvPr id="4" name="Slide Number Placeholder 3"/>
+          <p:cNvSpPr>
+            <a:spLocks noGrp="1"/>
+          </p:cNvSpPr>
+          <p:nvPr>
+            <p:ph type="sldNum" sz="quarter" idx="10"/>
+          </p:nvPr>
+        </p:nvSpPr>
+        <p:spPr/>
+        <p:txBody>
+          <a:bodyPr/>
+          <a:lstStyle/>
+          <a:p>
+            <a:fld id="{F7021451-1387-4CA6-816F-3879F97B5CBC}" type="slidenum">
+              <a:rPr lang="en-US"/>
+              <a:t>20</a:t>
+            </a:fld>
+            <a:endParaRPr lang="en-US"/>
+          </a:p>
+        </p:txBody>
+      </p:sp>
+    </p:spTree>
+    <p:extLst>
+      <p:ext uri="{BB962C8B-B14F-4D97-AF65-F5344CB8AC3E}">
+        <p14:creationId xmlns:p14="http://schemas.microsoft.com/office/powerpoint/2010/main" val="1024086991"/>
+      </p:ext>
+    </p:extLst>
+  </p:cSld>
+  <p:clrMapOvr>
+    <a:masterClrMapping/>
+  </p:clrMapOvr>
+</p:notes>
+</file>
+
+<file path=ppt/notesSlides/notesSlide21.xml><?xml version="1.0" encoding="utf-8"?>
+<p:notes xmlns:a="http://schemas.openxmlformats.org/drawingml/2006/main" xmlns:r="http://schemas.openxmlformats.org/officeDocument/2006/relationships" xmlns:p="http://schemas.openxmlformats.org/presentationml/2006/main">
+  <p:cSld>
+    <p:spTree>
+      <p:nvGrpSpPr>
+        <p:cNvPr id="1" name=""/>
+        <p:cNvGrpSpPr/>
+        <p:nvPr/>
+      </p:nvGrpSpPr>
+      <p:grpSpPr>
+        <a:xfrm>
+          <a:off x="0" y="0"/>
+          <a:ext cx="0" cy="0"/>
+          <a:chOff x="0" y="0"/>
+          <a:chExt cx="0" cy="0"/>
+        </a:xfrm>
+      </p:grpSpPr>
+      <p:sp>
+        <p:nvSpPr>
+          <p:cNvPr id="2" name="Slide Image Placeholder 1"/>
+          <p:cNvSpPr>
+            <a:spLocks noGrp="1" noRot="1" noChangeAspect="1"/>
+          </p:cNvSpPr>
+          <p:nvPr>
+            <p:ph type="sldImg"/>
+          </p:nvPr>
+        </p:nvSpPr>
+        <p:spPr/>
+      </p:sp>
+      <p:sp>
+        <p:nvSpPr>
+          <p:cNvPr id="3" name="Notes Placeholder 2"/>
+          <p:cNvSpPr>
+            <a:spLocks noGrp="1"/>
+          </p:cNvSpPr>
+          <p:nvPr>
+            <p:ph type="body" idx="1"/>
+          </p:nvPr>
+        </p:nvSpPr>
+        <p:spPr/>
+        <p:txBody>
+          <a:bodyPr/>
+          <a:lstStyle/>
+          <a:p>
+            <a:r>
+              <a:rPr lang="en-US" dirty="0"/>
+              <a:t>Same discipline as the chatbot math. Vendors quote only savings. Downtime
+avoided is usually the biggest line but hardest to estimate honestly. Numbers
+illustrative.</a:t>
+            </a:r>
+            <a:endParaRPr lang="en-US" dirty="0"/>
+          </a:p>
+        </p:txBody>
+      </p:sp>
+      <p:sp>
+        <p:nvSpPr>
+          <p:cNvPr id="4" name="Slide Number Placeholder 3"/>
+          <p:cNvSpPr>
+            <a:spLocks noGrp="1"/>
+          </p:cNvSpPr>
+          <p:nvPr>
+            <p:ph type="sldNum" sz="quarter" idx="10"/>
+          </p:nvPr>
+        </p:nvSpPr>
+        <p:spPr/>
+        <p:txBody>
+          <a:bodyPr/>
+          <a:lstStyle/>
+          <a:p>
+            <a:fld id="{F7021451-1387-4CA6-816F-3879F97B5CBC}" type="slidenum">
+              <a:rPr lang="en-US"/>
+              <a:t>21</a:t>
+            </a:fld>
+            <a:endParaRPr lang="en-US"/>
+          </a:p>
+        </p:txBody>
+      </p:sp>
+    </p:spTree>
+    <p:extLst>
+      <p:ext uri="{BB962C8B-B14F-4D97-AF65-F5344CB8AC3E}">
+        <p14:creationId xmlns:p14="http://schemas.microsoft.com/office/powerpoint/2010/main" val="1024086991"/>
+      </p:ext>
+    </p:extLst>
+  </p:cSld>
+  <p:clrMapOvr>
+    <a:masterClrMapping/>
+  </p:clrMapOvr>
+</p:notes>
+</file>
+
+<file path=ppt/notesSlides/notesSlide22.xml><?xml version="1.0" encoding="utf-8"?>
 <p:notes xmlns:a="http://schemas.openxmlformats.org/drawingml/2006/main" xmlns:r="http://schemas.openxmlformats.org/officeDocument/2006/relationships" xmlns:p="http://schemas.openxmlformats.org/presentationml/2006/main">
   <p:cSld>
     <p:spTree>
@@ -1444,7 +1808,7 @@
           <a:p>
             <a:fld id="{F7021451-1387-4CA6-816F-3879F97B5CBC}" type="slidenum">
               <a:rPr lang="en-US"/>
-              <a:t>19</a:t>
+              <a:t>22</a:t>
             </a:fld>
             <a:endParaRPr lang="en-US"/>
           </a:p>
@@ -1463,96 +1827,7 @@
 </p:notes>
 </file>
 
-<file path=ppt/notesSlides/notesSlide2.xml><?xml version="1.0" encoding="utf-8"?>
-<p:notes xmlns:a="http://schemas.openxmlformats.org/drawingml/2006/main" xmlns:r="http://schemas.openxmlformats.org/officeDocument/2006/relationships" xmlns:p="http://schemas.openxmlformats.org/presentationml/2006/main">
-  <p:cSld>
-    <p:spTree>
-      <p:nvGrpSpPr>
-        <p:cNvPr id="1" name=""/>
-        <p:cNvGrpSpPr/>
-        <p:nvPr/>
-      </p:nvGrpSpPr>
-      <p:grpSpPr>
-        <a:xfrm>
-          <a:off x="0" y="0"/>
-          <a:ext cx="0" cy="0"/>
-          <a:chOff x="0" y="0"/>
-          <a:chExt cx="0" cy="0"/>
-        </a:xfrm>
-      </p:grpSpPr>
-      <p:sp>
-        <p:nvSpPr>
-          <p:cNvPr id="2" name="Slide Image Placeholder 1"/>
-          <p:cNvSpPr>
-            <a:spLocks noGrp="1" noRot="1" noChangeAspect="1"/>
-          </p:cNvSpPr>
-          <p:nvPr>
-            <p:ph type="sldImg"/>
-          </p:nvPr>
-        </p:nvSpPr>
-        <p:spPr/>
-      </p:sp>
-      <p:sp>
-        <p:nvSpPr>
-          <p:cNvPr id="3" name="Notes Placeholder 2"/>
-          <p:cNvSpPr>
-            <a:spLocks noGrp="1"/>
-          </p:cNvSpPr>
-          <p:nvPr>
-            <p:ph type="body" idx="1"/>
-          </p:nvPr>
-        </p:nvSpPr>
-        <p:spPr/>
-        <p:txBody>
-          <a:bodyPr/>
-          <a:lstStyle/>
-          <a:p>
-            <a:r>
-              <a:rPr lang="en-US" dirty="0"/>
-              <a:t>~35-45 min. Stop me with questions during the layers; hold strategy questions
-for the business section where they'll be answered.</a:t>
-            </a:r>
-            <a:endParaRPr lang="en-US" dirty="0"/>
-          </a:p>
-        </p:txBody>
-      </p:sp>
-      <p:sp>
-        <p:nvSpPr>
-          <p:cNvPr id="4" name="Slide Number Placeholder 3"/>
-          <p:cNvSpPr>
-            <a:spLocks noGrp="1"/>
-          </p:cNvSpPr>
-          <p:nvPr>
-            <p:ph type="sldNum" sz="quarter" idx="10"/>
-          </p:nvPr>
-        </p:nvSpPr>
-        <p:spPr/>
-        <p:txBody>
-          <a:bodyPr/>
-          <a:lstStyle/>
-          <a:p>
-            <a:fld id="{F7021451-1387-4CA6-816F-3879F97B5CBC}" type="slidenum">
-              <a:rPr lang="en-US"/>
-              <a:t>2</a:t>
-            </a:fld>
-            <a:endParaRPr lang="en-US"/>
-          </a:p>
-        </p:txBody>
-      </p:sp>
-    </p:spTree>
-    <p:extLst>
-      <p:ext uri="{BB962C8B-B14F-4D97-AF65-F5344CB8AC3E}">
-        <p14:creationId xmlns:p14="http://schemas.microsoft.com/office/powerpoint/2010/main" val="1024086991"/>
-      </p:ext>
-    </p:extLst>
-  </p:cSld>
-  <p:clrMapOvr>
-    <a:masterClrMapping/>
-  </p:clrMapOvr>
-</p:notes>
-</file>
-
-<file path=ppt/notesSlides/notesSlide20.xml><?xml version="1.0" encoding="utf-8"?>
+<file path=ppt/notesSlides/notesSlide23.xml><?xml version="1.0" encoding="utf-8"?>
 <p:notes xmlns:a="http://schemas.openxmlformats.org/drawingml/2006/main" xmlns:r="http://schemas.openxmlformats.org/officeDocument/2006/relationships" xmlns:p="http://schemas.openxmlformats.org/presentationml/2006/main">
   <p:cSld>
     <p:spTree>
@@ -1622,7 +1897,7 @@
           <a:p>
             <a:fld id="{F7021451-1387-4CA6-816F-3879F97B5CBC}" type="slidenum">
               <a:rPr lang="en-US"/>
-              <a:t>20</a:t>
+              <a:t>23</a:t>
             </a:fld>
             <a:endParaRPr lang="en-US"/>
           </a:p>
@@ -1641,7 +1916,7 @@
 </p:notes>
 </file>
 
-<file path=ppt/notesSlides/notesSlide21.xml><?xml version="1.0" encoding="utf-8"?>
+<file path=ppt/notesSlides/notesSlide24.xml><?xml version="1.0" encoding="utf-8"?>
 <p:notes xmlns:a="http://schemas.openxmlformats.org/drawingml/2006/main" xmlns:r="http://schemas.openxmlformats.org/officeDocument/2006/relationships" xmlns:p="http://schemas.openxmlformats.org/presentationml/2006/main">
   <p:cSld>
     <p:spTree>
@@ -1712,7 +1987,7 @@
           <a:p>
             <a:fld id="{F7021451-1387-4CA6-816F-3879F97B5CBC}" type="slidenum">
               <a:rPr lang="en-US"/>
-              <a:t>21</a:t>
+              <a:t>24</a:t>
             </a:fld>
             <a:endParaRPr lang="en-US"/>
           </a:p>
@@ -3174,6 +3449,123 @@
 <file path=ppt/slides/slide21.xml><?xml version="1.0" encoding="utf-8"?>
 <p:sld xmlns:a="http://schemas.openxmlformats.org/drawingml/2006/main" xmlns:r="http://schemas.openxmlformats.org/officeDocument/2006/relationships" xmlns:p="http://schemas.openxmlformats.org/presentationml/2006/main">
   <p:cSld name="Slide 21">
+    <p:bg>
+      <p:bgPr>
+        <a:blipFill dpi="0" rotWithShape="1">
+          <a:blip r:embed="rId1">
+            <a:lum/>
+          </a:blip>
+          <a:srcRect/>
+          <a:stretch>
+            <a:fillRect/>
+          </a:stretch>
+        </a:blipFill>
+        <a:effectLst/>
+      </p:bgPr>
+    </p:bg>
+    <p:spTree>
+      <p:nvGrpSpPr>
+        <p:cNvPr id="1" name=""/>
+        <p:cNvGrpSpPr/>
+        <p:nvPr/>
+      </p:nvGrpSpPr>
+      <p:grpSpPr>
+        <a:xfrm>
+          <a:off x="0" y="0"/>
+          <a:ext cx="0" cy="0"/>
+          <a:chOff x="0" y="0"/>
+          <a:chExt cx="0" cy="0"/>
+        </a:xfrm>
+      </p:grpSpPr>
+    </p:spTree>
+  </p:cSld>
+  <p:clrMapOvr>
+    <a:masterClrMapping/>
+  </p:clrMapOvr>
+</p:sld>
+</file>
+
+<file path=ppt/slides/slide22.xml><?xml version="1.0" encoding="utf-8"?>
+<p:sld xmlns:a="http://schemas.openxmlformats.org/drawingml/2006/main" xmlns:r="http://schemas.openxmlformats.org/officeDocument/2006/relationships" xmlns:p="http://schemas.openxmlformats.org/presentationml/2006/main">
+  <p:cSld name="Slide 22">
+    <p:bg>
+      <p:bgPr>
+        <a:blipFill dpi="0" rotWithShape="1">
+          <a:blip r:embed="rId1">
+            <a:lum/>
+          </a:blip>
+          <a:srcRect/>
+          <a:stretch>
+            <a:fillRect/>
+          </a:stretch>
+        </a:blipFill>
+        <a:effectLst/>
+      </p:bgPr>
+    </p:bg>
+    <p:spTree>
+      <p:nvGrpSpPr>
+        <p:cNvPr id="1" name=""/>
+        <p:cNvGrpSpPr/>
+        <p:nvPr/>
+      </p:nvGrpSpPr>
+      <p:grpSpPr>
+        <a:xfrm>
+          <a:off x="0" y="0"/>
+          <a:ext cx="0" cy="0"/>
+          <a:chOff x="0" y="0"/>
+          <a:chExt cx="0" cy="0"/>
+        </a:xfrm>
+      </p:grpSpPr>
+    </p:spTree>
+  </p:cSld>
+  <p:clrMapOvr>
+    <a:masterClrMapping/>
+  </p:clrMapOvr>
+</p:sld>
+</file>
+
+<file path=ppt/slides/slide23.xml><?xml version="1.0" encoding="utf-8"?>
+<p:sld xmlns:a="http://schemas.openxmlformats.org/drawingml/2006/main" xmlns:r="http://schemas.openxmlformats.org/officeDocument/2006/relationships" xmlns:p="http://schemas.openxmlformats.org/presentationml/2006/main">
+  <p:cSld name="Slide 23">
+    <p:bg>
+      <p:bgPr>
+        <a:blipFill dpi="0" rotWithShape="1">
+          <a:blip r:embed="rId1">
+            <a:lum/>
+          </a:blip>
+          <a:srcRect/>
+          <a:stretch>
+            <a:fillRect/>
+          </a:stretch>
+        </a:blipFill>
+        <a:effectLst/>
+      </p:bgPr>
+    </p:bg>
+    <p:spTree>
+      <p:nvGrpSpPr>
+        <p:cNvPr id="1" name=""/>
+        <p:cNvGrpSpPr/>
+        <p:nvPr/>
+      </p:nvGrpSpPr>
+      <p:grpSpPr>
+        <a:xfrm>
+          <a:off x="0" y="0"/>
+          <a:ext cx="0" cy="0"/>
+          <a:chOff x="0" y="0"/>
+          <a:chExt cx="0" cy="0"/>
+        </a:xfrm>
+      </p:grpSpPr>
+    </p:spTree>
+  </p:cSld>
+  <p:clrMapOvr>
+    <a:masterClrMapping/>
+  </p:clrMapOvr>
+</p:sld>
+</file>
+
+<file path=ppt/slides/slide24.xml><?xml version="1.0" encoding="utf-8"?>
+<p:sld xmlns:a="http://schemas.openxmlformats.org/drawingml/2006/main" xmlns:r="http://schemas.openxmlformats.org/officeDocument/2006/relationships" xmlns:p="http://schemas.openxmlformats.org/presentationml/2006/main">
+  <p:cSld name="Slide 24">
     <p:bg>
       <p:bgPr>
         <a:blipFill dpi="0" rotWithShape="1">

</xml_diff>

<commit_message>
Rename section to GenAI for DevOps; add IaC slide; drop DORA
- Section title SRE -> "GenAI for DevOps"; remove subtitle line
- Clean up the incident/RCA slide (tools inline, numbers in a table)
- Add "Infrastructure as Code with AI" slide + case (Terraform/Pulumi:
  generate, explain plan, policy-as-code, drift; Pulumi Neo/env0/Spacelift)
- Remove the DORA 2024 counterpoint (off-topic); adjust takeaways/notes

Co-Authored-By: Claude Opus 4.8 (1M context) <noreply@anthropic.com>
</commit_message>
<xml_diff>
--- a/slides.pptx
+++ b/slides.pptx
@@ -1153,9 +1153,9 @@
           <a:p>
             <a:r>
               <a:rPr lang="en-US" dirty="0"/>
-              <a:t>Reframe: coding assistants help app devs, not platform/SRE. This section is the
-GenAI-for-SRE job: triage, RCA, runbooks, observability, CI/CD risk. And it's
-the capstone — it uses every layer we just covered.</a:t>
+              <a:t>The platform/DevOps job: incident triage, RCA, runbooks, observability, IaC, and
+CI/CD risk. It's the capstone — it uses every layer we just covered. (Coding
+assistants are dev productivity — a different thing.)</a:t>
             </a:r>
             <a:endParaRPr lang="en-US" dirty="0"/>
           </a:p>
@@ -1603,9 +1603,9 @@
           <a:p>
             <a:r>
               <a:rPr lang="en-US" dirty="0"/>
-              <a:t>Area 4 of the JD. Be candid: this is greenfield. Great project territory for
-students. Naturally leads into DORA — speed at the deploy gate without
-discipline is dangerous.</a:t>
+              <a:t>Squarely the DevOps day job. The killer use is "explain this plan" — turning a
+scary diff into a sentence. But the discipline line matters: never apply
+AI-written IaC unscanned. AI drafts; tfsec/Checkov/OPA gate it.</a:t>
             </a:r>
             <a:endParaRPr lang="en-US" dirty="0"/>
           </a:p>
@@ -1648,6 +1648,95 @@
 </file>
 
 <file path=ppt/notesSlides/notesSlide21.xml><?xml version="1.0" encoding="utf-8"?>
+<p:notes xmlns:a="http://schemas.openxmlformats.org/drawingml/2006/main" xmlns:r="http://schemas.openxmlformats.org/officeDocument/2006/relationships" xmlns:p="http://schemas.openxmlformats.org/presentationml/2006/main">
+  <p:cSld>
+    <p:spTree>
+      <p:nvGrpSpPr>
+        <p:cNvPr id="1" name=""/>
+        <p:cNvGrpSpPr/>
+        <p:nvPr/>
+      </p:nvGrpSpPr>
+      <p:grpSpPr>
+        <a:xfrm>
+          <a:off x="0" y="0"/>
+          <a:ext cx="0" cy="0"/>
+          <a:chOff x="0" y="0"/>
+          <a:chExt cx="0" cy="0"/>
+        </a:xfrm>
+      </p:grpSpPr>
+      <p:sp>
+        <p:nvSpPr>
+          <p:cNvPr id="2" name="Slide Image Placeholder 1"/>
+          <p:cNvSpPr>
+            <a:spLocks noGrp="1" noRot="1" noChangeAspect="1"/>
+          </p:cNvSpPr>
+          <p:nvPr>
+            <p:ph type="sldImg"/>
+          </p:nvPr>
+        </p:nvSpPr>
+        <p:spPr/>
+      </p:sp>
+      <p:sp>
+        <p:nvSpPr>
+          <p:cNvPr id="3" name="Notes Placeholder 2"/>
+          <p:cNvSpPr>
+            <a:spLocks noGrp="1"/>
+          </p:cNvSpPr>
+          <p:nvPr>
+            <p:ph type="body" idx="1"/>
+          </p:nvPr>
+        </p:nvSpPr>
+        <p:spPr/>
+        <p:txBody>
+          <a:bodyPr/>
+          <a:lstStyle/>
+          <a:p>
+            <a:r>
+              <a:rPr lang="en-US" dirty="0"/>
+              <a:t>Area 4 of the JD. Be candid: this is greenfield. Great project territory for
+students — risk scoring and auto-rollback from historical outcomes.</a:t>
+            </a:r>
+            <a:endParaRPr lang="en-US" dirty="0"/>
+          </a:p>
+        </p:txBody>
+      </p:sp>
+      <p:sp>
+        <p:nvSpPr>
+          <p:cNvPr id="4" name="Slide Number Placeholder 3"/>
+          <p:cNvSpPr>
+            <a:spLocks noGrp="1"/>
+          </p:cNvSpPr>
+          <p:nvPr>
+            <p:ph type="sldNum" sz="quarter" idx="10"/>
+          </p:nvPr>
+        </p:nvSpPr>
+        <p:spPr/>
+        <p:txBody>
+          <a:bodyPr/>
+          <a:lstStyle/>
+          <a:p>
+            <a:fld id="{F7021451-1387-4CA6-816F-3879F97B5CBC}" type="slidenum">
+              <a:rPr lang="en-US"/>
+              <a:t>21</a:t>
+            </a:fld>
+            <a:endParaRPr lang="en-US"/>
+          </a:p>
+        </p:txBody>
+      </p:sp>
+    </p:spTree>
+    <p:extLst>
+      <p:ext uri="{BB962C8B-B14F-4D97-AF65-F5344CB8AC3E}">
+        <p14:creationId xmlns:p14="http://schemas.microsoft.com/office/powerpoint/2010/main" val="1024086991"/>
+      </p:ext>
+    </p:extLst>
+  </p:cSld>
+  <p:clrMapOvr>
+    <a:masterClrMapping/>
+  </p:clrMapOvr>
+</p:notes>
+</file>
+
+<file path=ppt/notesSlides/notesSlide22.xml><?xml version="1.0" encoding="utf-8"?>
 <p:notes xmlns:a="http://schemas.openxmlformats.org/drawingml/2006/main" xmlns:r="http://schemas.openxmlformats.org/officeDocument/2006/relationships" xmlns:p="http://schemas.openxmlformats.org/presentationml/2006/main">
   <p:cSld>
     <p:spTree>
@@ -1718,7 +1807,7 @@
           <a:p>
             <a:fld id="{F7021451-1387-4CA6-816F-3879F97B5CBC}" type="slidenum">
               <a:rPr lang="en-US"/>
-              <a:t>21</a:t>
+              <a:t>22</a:t>
             </a:fld>
             <a:endParaRPr lang="en-US"/>
           </a:p>
@@ -1737,7 +1826,7 @@
 </p:notes>
 </file>
 
-<file path=ppt/notesSlides/notesSlide22.xml><?xml version="1.0" encoding="utf-8"?>
+<file path=ppt/notesSlides/notesSlide23.xml><?xml version="1.0" encoding="utf-8"?>
 <p:notes xmlns:a="http://schemas.openxmlformats.org/drawingml/2006/main" xmlns:r="http://schemas.openxmlformats.org/officeDocument/2006/relationships" xmlns:p="http://schemas.openxmlformats.org/presentationml/2006/main">
   <p:cSld>
     <p:spTree>
@@ -1783,9 +1872,8 @@
           <a:p>
             <a:r>
               <a:rPr lang="en-US" dirty="0"/>
-              <a:t>The most important slide for this audience. AI is not a silver bullet. Your job
-— pipelines, testing, small batches — matters MORE in the AI era, not less. End
-the DevOps section on this.</a:t>
+              <a:t>Recap in 30 seconds, then open Q&amp;A. If short on time, slides 5 (layers),
+the pyramid, and the AI-agent-as-whole-stack are the must-keeps.</a:t>
             </a:r>
             <a:endParaRPr lang="en-US" dirty="0"/>
           </a:p>
@@ -1808,7 +1896,7 @@
           <a:p>
             <a:fld id="{F7021451-1387-4CA6-816F-3879F97B5CBC}" type="slidenum">
               <a:rPr lang="en-US"/>
-              <a:t>22</a:t>
+              <a:t>23</a:t>
             </a:fld>
             <a:endParaRPr lang="en-US"/>
           </a:p>
@@ -1827,95 +1915,6 @@
 </p:notes>
 </file>
 
-<file path=ppt/notesSlides/notesSlide23.xml><?xml version="1.0" encoding="utf-8"?>
-<p:notes xmlns:a="http://schemas.openxmlformats.org/drawingml/2006/main" xmlns:r="http://schemas.openxmlformats.org/officeDocument/2006/relationships" xmlns:p="http://schemas.openxmlformats.org/presentationml/2006/main">
-  <p:cSld>
-    <p:spTree>
-      <p:nvGrpSpPr>
-        <p:cNvPr id="1" name=""/>
-        <p:cNvGrpSpPr/>
-        <p:nvPr/>
-      </p:nvGrpSpPr>
-      <p:grpSpPr>
-        <a:xfrm>
-          <a:off x="0" y="0"/>
-          <a:ext cx="0" cy="0"/>
-          <a:chOff x="0" y="0"/>
-          <a:chExt cx="0" cy="0"/>
-        </a:xfrm>
-      </p:grpSpPr>
-      <p:sp>
-        <p:nvSpPr>
-          <p:cNvPr id="2" name="Slide Image Placeholder 1"/>
-          <p:cNvSpPr>
-            <a:spLocks noGrp="1" noRot="1" noChangeAspect="1"/>
-          </p:cNvSpPr>
-          <p:nvPr>
-            <p:ph type="sldImg"/>
-          </p:nvPr>
-        </p:nvSpPr>
-        <p:spPr/>
-      </p:sp>
-      <p:sp>
-        <p:nvSpPr>
-          <p:cNvPr id="3" name="Notes Placeholder 2"/>
-          <p:cNvSpPr>
-            <a:spLocks noGrp="1"/>
-          </p:cNvSpPr>
-          <p:nvPr>
-            <p:ph type="body" idx="1"/>
-          </p:nvPr>
-        </p:nvSpPr>
-        <p:spPr/>
-        <p:txBody>
-          <a:bodyPr/>
-          <a:lstStyle/>
-          <a:p>
-            <a:r>
-              <a:rPr lang="en-US" dirty="0"/>
-              <a:t>Recap in 30 seconds, then open Q&amp;A. If short on time, slides 5 (layers),
-pyramid, and DORA are the must-keeps.</a:t>
-            </a:r>
-            <a:endParaRPr lang="en-US" dirty="0"/>
-          </a:p>
-        </p:txBody>
-      </p:sp>
-      <p:sp>
-        <p:nvSpPr>
-          <p:cNvPr id="4" name="Slide Number Placeholder 3"/>
-          <p:cNvSpPr>
-            <a:spLocks noGrp="1"/>
-          </p:cNvSpPr>
-          <p:nvPr>
-            <p:ph type="sldNum" sz="quarter" idx="10"/>
-          </p:nvPr>
-        </p:nvSpPr>
-        <p:spPr/>
-        <p:txBody>
-          <a:bodyPr/>
-          <a:lstStyle/>
-          <a:p>
-            <a:fld id="{F7021451-1387-4CA6-816F-3879F97B5CBC}" type="slidenum">
-              <a:rPr lang="en-US"/>
-              <a:t>23</a:t>
-            </a:fld>
-            <a:endParaRPr lang="en-US"/>
-          </a:p>
-        </p:txBody>
-      </p:sp>
-    </p:spTree>
-    <p:extLst>
-      <p:ext uri="{BB962C8B-B14F-4D97-AF65-F5344CB8AC3E}">
-        <p14:creationId xmlns:p14="http://schemas.microsoft.com/office/powerpoint/2010/main" val="1024086991"/>
-      </p:ext>
-    </p:extLst>
-  </p:cSld>
-  <p:clrMapOvr>
-    <a:masterClrMapping/>
-  </p:clrMapOvr>
-</p:notes>
-</file>
-
 <file path=ppt/notesSlides/notesSlide24.xml><?xml version="1.0" encoding="utf-8"?>
 <p:notes xmlns:a="http://schemas.openxmlformats.org/drawingml/2006/main" xmlns:r="http://schemas.openxmlformats.org/officeDocument/2006/relationships" xmlns:p="http://schemas.openxmlformats.org/presentationml/2006/main">
   <p:cSld>
@@ -1963,7 +1962,7 @@
             <a:r>
               <a:rPr lang="en-US" dirty="0"/>
               <a:t>Likely questions: "should we train our own model?" (no — use/fine-tune/RAG);
-"will AI replace devs?" (Klarna rehired; DORA shows fundamentals win);
+"will AI replace devs?" (Klarna rehired; remediation stays human-in-the-loop);
 "gross vs net revenue?" (Anthropic example).</a:t>
             </a:r>
             <a:endParaRPr lang="en-US" dirty="0"/>

</xml_diff>

<commit_message>
Rework IaC into plausible-code risk + 3-layer defense; drop Pulumi & economics
- Remove Pulumi (Terraform-only focus)
- Replace generic IaC slide with three: the "plausible code" risk, the
  top misconfigurations AI generates, and the 3-layer defense
  (AI generate -> human review -> policy-as-code gate)
- Remove the AI-SRE economics slide
- Mirror all changes in docs/devops-cases.md; re-render PDF/PPTX

Co-Authored-By: Claude Opus 4.8 (1M context) <noreply@anthropic.com>
</commit_message>
<xml_diff>
--- a/slides.pptx
+++ b/slides.pptx
@@ -29,9 +29,10 @@
     <p:sldId id="277" r:id="rId23"/>
     <p:sldId id="278" r:id="rId24"/>
     <p:sldId id="279" r:id="rId25"/>
+    <p:sldId id="280" r:id="rId26"/>
   </p:sldIdLst>
   <p:notesMasterIdLst>
-    <p:notesMasterId r:id="rId26"/>
+    <p:notesMasterId r:id="rId27"/>
   </p:notesMasterIdLst>
   <p:sldSz cx="12192000" cy="6858000"/>
   <p:notesSz cx="6858000" cy="12192000"/>
@@ -1603,9 +1604,10 @@
           <a:p>
             <a:r>
               <a:rPr lang="en-US" dirty="0"/>
-              <a:t>Squarely the DevOps day job. The killer use is "explain this plan" — turning a
-scary diff into a sentence. But the discipline line matters: never apply
-AI-written IaC unscanned. AI drafts; tfsec/Checkov/OPA gate it.</a:t>
+              <a:t>Core message of this part. Generate ~30s, review &lt;60s — speed becomes a security
+hole when review turns into "tick the box." Second risk: mental-model loss. If a
+team stops writing HCL by hand, ask someone to explain an AI module line-by-line
+with no docs — if &gt;20% can't, that's a dangerous gap.</a:t>
             </a:r>
             <a:endParaRPr lang="en-US" dirty="0"/>
           </a:p>
@@ -1648,6 +1650,185 @@
 </file>
 
 <file path=ppt/notesSlides/notesSlide21.xml><?xml version="1.0" encoding="utf-8"?>
+<p:notes xmlns:a="http://schemas.openxmlformats.org/drawingml/2006/main" xmlns:r="http://schemas.openxmlformats.org/officeDocument/2006/relationships" xmlns:p="http://schemas.openxmlformats.org/presentationml/2006/main">
+  <p:cSld>
+    <p:spTree>
+      <p:nvGrpSpPr>
+        <p:cNvPr id="1" name=""/>
+        <p:cNvGrpSpPr/>
+        <p:nvPr/>
+      </p:nvGrpSpPr>
+      <p:grpSpPr>
+        <a:xfrm>
+          <a:off x="0" y="0"/>
+          <a:ext cx="0" cy="0"/>
+          <a:chOff x="0" y="0"/>
+          <a:chExt cx="0" cy="0"/>
+        </a:xfrm>
+      </p:grpSpPr>
+      <p:sp>
+        <p:nvSpPr>
+          <p:cNvPr id="2" name="Slide Image Placeholder 1"/>
+          <p:cNvSpPr>
+            <a:spLocks noGrp="1" noRot="1" noChangeAspect="1"/>
+          </p:cNvSpPr>
+          <p:nvPr>
+            <p:ph type="sldImg"/>
+          </p:nvPr>
+        </p:nvSpPr>
+        <p:spPr/>
+      </p:sp>
+      <p:sp>
+        <p:nvSpPr>
+          <p:cNvPr id="3" name="Notes Placeholder 2"/>
+          <p:cNvSpPr>
+            <a:spLocks noGrp="1"/>
+          </p:cNvSpPr>
+          <p:nvPr>
+            <p:ph type="body" idx="1"/>
+          </p:nvPr>
+        </p:nvSpPr>
+        <p:spPr/>
+        <p:txBody>
+          <a:bodyPr/>
+          <a:lstStyle/>
+          <a:p>
+            <a:r>
+              <a:rPr lang="en-US" dirty="0"/>
+              <a:t>Frequencies are illustrative teaching figures, not a benchmark. The pattern is
+real: the model reproduces demo-grade defaults, which are exactly wrong for prod.</a:t>
+            </a:r>
+            <a:endParaRPr lang="en-US" dirty="0"/>
+          </a:p>
+        </p:txBody>
+      </p:sp>
+      <p:sp>
+        <p:nvSpPr>
+          <p:cNvPr id="4" name="Slide Number Placeholder 3"/>
+          <p:cNvSpPr>
+            <a:spLocks noGrp="1"/>
+          </p:cNvSpPr>
+          <p:nvPr>
+            <p:ph type="sldNum" sz="quarter" idx="10"/>
+          </p:nvPr>
+        </p:nvSpPr>
+        <p:spPr/>
+        <p:txBody>
+          <a:bodyPr/>
+          <a:lstStyle/>
+          <a:p>
+            <a:fld id="{F7021451-1387-4CA6-816F-3879F97B5CBC}" type="slidenum">
+              <a:rPr lang="en-US"/>
+              <a:t>21</a:t>
+            </a:fld>
+            <a:endParaRPr lang="en-US"/>
+          </a:p>
+        </p:txBody>
+      </p:sp>
+    </p:spTree>
+    <p:extLst>
+      <p:ext uri="{BB962C8B-B14F-4D97-AF65-F5344CB8AC3E}">
+        <p14:creationId xmlns:p14="http://schemas.microsoft.com/office/powerpoint/2010/main" val="1024086991"/>
+      </p:ext>
+    </p:extLst>
+  </p:cSld>
+  <p:clrMapOvr>
+    <a:masterClrMapping/>
+  </p:clrMapOvr>
+</p:notes>
+</file>
+
+<file path=ppt/notesSlides/notesSlide22.xml><?xml version="1.0" encoding="utf-8"?>
+<p:notes xmlns:a="http://schemas.openxmlformats.org/drawingml/2006/main" xmlns:r="http://schemas.openxmlformats.org/officeDocument/2006/relationships" xmlns:p="http://schemas.openxmlformats.org/presentationml/2006/main">
+  <p:cSld>
+    <p:spTree>
+      <p:nvGrpSpPr>
+        <p:cNvPr id="1" name=""/>
+        <p:cNvGrpSpPr/>
+        <p:nvPr/>
+      </p:nvGrpSpPr>
+      <p:grpSpPr>
+        <a:xfrm>
+          <a:off x="0" y="0"/>
+          <a:ext cx="0" cy="0"/>
+          <a:chOff x="0" y="0"/>
+          <a:chExt cx="0" cy="0"/>
+        </a:xfrm>
+      </p:grpSpPr>
+      <p:sp>
+        <p:nvSpPr>
+          <p:cNvPr id="2" name="Slide Image Placeholder 1"/>
+          <p:cNvSpPr>
+            <a:spLocks noGrp="1" noRot="1" noChangeAspect="1"/>
+          </p:cNvSpPr>
+          <p:nvPr>
+            <p:ph type="sldImg"/>
+          </p:nvPr>
+        </p:nvSpPr>
+        <p:spPr/>
+      </p:sp>
+      <p:sp>
+        <p:nvSpPr>
+          <p:cNvPr id="3" name="Notes Placeholder 2"/>
+          <p:cNvSpPr>
+            <a:spLocks noGrp="1"/>
+          </p:cNvSpPr>
+          <p:nvPr>
+            <p:ph type="body" idx="1"/>
+          </p:nvPr>
+        </p:nvSpPr>
+        <p:spPr/>
+        <p:txBody>
+          <a:bodyPr/>
+          <a:lstStyle/>
+          <a:p>
+            <a:r>
+              <a:rPr lang="en-US" dirty="0"/>
+              <a:t>This is the payoff pattern. No single layer is enough: speed (L1) needs judgment
+(L2) needs an automated gate (L3). The hard rule lives in L3 — a failing checkov
+HIGH blocks apply, no exceptions. That's how you keep AI's speed without its risk.</a:t>
+            </a:r>
+            <a:endParaRPr lang="en-US" dirty="0"/>
+          </a:p>
+        </p:txBody>
+      </p:sp>
+      <p:sp>
+        <p:nvSpPr>
+          <p:cNvPr id="4" name="Slide Number Placeholder 3"/>
+          <p:cNvSpPr>
+            <a:spLocks noGrp="1"/>
+          </p:cNvSpPr>
+          <p:nvPr>
+            <p:ph type="sldNum" sz="quarter" idx="10"/>
+          </p:nvPr>
+        </p:nvSpPr>
+        <p:spPr/>
+        <p:txBody>
+          <a:bodyPr/>
+          <a:lstStyle/>
+          <a:p>
+            <a:fld id="{F7021451-1387-4CA6-816F-3879F97B5CBC}" type="slidenum">
+              <a:rPr lang="en-US"/>
+              <a:t>22</a:t>
+            </a:fld>
+            <a:endParaRPr lang="en-US"/>
+          </a:p>
+        </p:txBody>
+      </p:sp>
+    </p:spTree>
+    <p:extLst>
+      <p:ext uri="{BB962C8B-B14F-4D97-AF65-F5344CB8AC3E}">
+        <p14:creationId xmlns:p14="http://schemas.microsoft.com/office/powerpoint/2010/main" val="1024086991"/>
+      </p:ext>
+    </p:extLst>
+  </p:cSld>
+  <p:clrMapOvr>
+    <a:masterClrMapping/>
+  </p:clrMapOvr>
+</p:notes>
+</file>
+
+<file path=ppt/notesSlides/notesSlide23.xml><?xml version="1.0" encoding="utf-8"?>
 <p:notes xmlns:a="http://schemas.openxmlformats.org/drawingml/2006/main" xmlns:r="http://schemas.openxmlformats.org/officeDocument/2006/relationships" xmlns:p="http://schemas.openxmlformats.org/presentationml/2006/main">
   <p:cSld>
     <p:spTree>
@@ -1717,7 +1898,7 @@
           <a:p>
             <a:fld id="{F7021451-1387-4CA6-816F-3879F97B5CBC}" type="slidenum">
               <a:rPr lang="en-US"/>
-              <a:t>21</a:t>
+              <a:t>23</a:t>
             </a:fld>
             <a:endParaRPr lang="en-US"/>
           </a:p>
@@ -1736,97 +1917,7 @@
 </p:notes>
 </file>
 
-<file path=ppt/notesSlides/notesSlide22.xml><?xml version="1.0" encoding="utf-8"?>
-<p:notes xmlns:a="http://schemas.openxmlformats.org/drawingml/2006/main" xmlns:r="http://schemas.openxmlformats.org/officeDocument/2006/relationships" xmlns:p="http://schemas.openxmlformats.org/presentationml/2006/main">
-  <p:cSld>
-    <p:spTree>
-      <p:nvGrpSpPr>
-        <p:cNvPr id="1" name=""/>
-        <p:cNvGrpSpPr/>
-        <p:nvPr/>
-      </p:nvGrpSpPr>
-      <p:grpSpPr>
-        <a:xfrm>
-          <a:off x="0" y="0"/>
-          <a:ext cx="0" cy="0"/>
-          <a:chOff x="0" y="0"/>
-          <a:chExt cx="0" cy="0"/>
-        </a:xfrm>
-      </p:grpSpPr>
-      <p:sp>
-        <p:nvSpPr>
-          <p:cNvPr id="2" name="Slide Image Placeholder 1"/>
-          <p:cNvSpPr>
-            <a:spLocks noGrp="1" noRot="1" noChangeAspect="1"/>
-          </p:cNvSpPr>
-          <p:nvPr>
-            <p:ph type="sldImg"/>
-          </p:nvPr>
-        </p:nvSpPr>
-        <p:spPr/>
-      </p:sp>
-      <p:sp>
-        <p:nvSpPr>
-          <p:cNvPr id="3" name="Notes Placeholder 2"/>
-          <p:cNvSpPr>
-            <a:spLocks noGrp="1"/>
-          </p:cNvSpPr>
-          <p:nvPr>
-            <p:ph type="body" idx="1"/>
-          </p:nvPr>
-        </p:nvSpPr>
-        <p:spPr/>
-        <p:txBody>
-          <a:bodyPr/>
-          <a:lstStyle/>
-          <a:p>
-            <a:r>
-              <a:rPr lang="en-US" dirty="0"/>
-              <a:t>Same discipline as the chatbot math. Vendors quote only savings. Downtime
-avoided is usually the biggest line but hardest to estimate honestly. Numbers
-illustrative.</a:t>
-            </a:r>
-            <a:endParaRPr lang="en-US" dirty="0"/>
-          </a:p>
-        </p:txBody>
-      </p:sp>
-      <p:sp>
-        <p:nvSpPr>
-          <p:cNvPr id="4" name="Slide Number Placeholder 3"/>
-          <p:cNvSpPr>
-            <a:spLocks noGrp="1"/>
-          </p:cNvSpPr>
-          <p:nvPr>
-            <p:ph type="sldNum" sz="quarter" idx="10"/>
-          </p:nvPr>
-        </p:nvSpPr>
-        <p:spPr/>
-        <p:txBody>
-          <a:bodyPr/>
-          <a:lstStyle/>
-          <a:p>
-            <a:fld id="{F7021451-1387-4CA6-816F-3879F97B5CBC}" type="slidenum">
-              <a:rPr lang="en-US"/>
-              <a:t>22</a:t>
-            </a:fld>
-            <a:endParaRPr lang="en-US"/>
-          </a:p>
-        </p:txBody>
-      </p:sp>
-    </p:spTree>
-    <p:extLst>
-      <p:ext uri="{BB962C8B-B14F-4D97-AF65-F5344CB8AC3E}">
-        <p14:creationId xmlns:p14="http://schemas.microsoft.com/office/powerpoint/2010/main" val="1024086991"/>
-      </p:ext>
-    </p:extLst>
-  </p:cSld>
-  <p:clrMapOvr>
-    <a:masterClrMapping/>
-  </p:clrMapOvr>
-</p:notes>
-</file>
-
-<file path=ppt/notesSlides/notesSlide23.xml><?xml version="1.0" encoding="utf-8"?>
+<file path=ppt/notesSlides/notesSlide24.xml><?xml version="1.0" encoding="utf-8"?>
 <p:notes xmlns:a="http://schemas.openxmlformats.org/drawingml/2006/main" xmlns:r="http://schemas.openxmlformats.org/officeDocument/2006/relationships" xmlns:p="http://schemas.openxmlformats.org/presentationml/2006/main">
   <p:cSld>
     <p:spTree>
@@ -1896,7 +1987,7 @@
           <a:p>
             <a:fld id="{F7021451-1387-4CA6-816F-3879F97B5CBC}" type="slidenum">
               <a:rPr lang="en-US"/>
-              <a:t>23</a:t>
+              <a:t>24</a:t>
             </a:fld>
             <a:endParaRPr lang="en-US"/>
           </a:p>
@@ -1915,7 +2006,7 @@
 </p:notes>
 </file>
 
-<file path=ppt/notesSlides/notesSlide24.xml><?xml version="1.0" encoding="utf-8"?>
+<file path=ppt/notesSlides/notesSlide25.xml><?xml version="1.0" encoding="utf-8"?>
 <p:notes xmlns:a="http://schemas.openxmlformats.org/drawingml/2006/main" xmlns:r="http://schemas.openxmlformats.org/officeDocument/2006/relationships" xmlns:p="http://schemas.openxmlformats.org/presentationml/2006/main">
   <p:cSld>
     <p:spTree>
@@ -1986,7 +2077,7 @@
           <a:p>
             <a:fld id="{F7021451-1387-4CA6-816F-3879F97B5CBC}" type="slidenum">
               <a:rPr lang="en-US"/>
-              <a:t>24</a:t>
+              <a:t>25</a:t>
             </a:fld>
             <a:endParaRPr lang="en-US"/>
           </a:p>
@@ -3565,6 +3656,45 @@
 <file path=ppt/slides/slide24.xml><?xml version="1.0" encoding="utf-8"?>
 <p:sld xmlns:a="http://schemas.openxmlformats.org/drawingml/2006/main" xmlns:r="http://schemas.openxmlformats.org/officeDocument/2006/relationships" xmlns:p="http://schemas.openxmlformats.org/presentationml/2006/main">
   <p:cSld name="Slide 24">
+    <p:bg>
+      <p:bgPr>
+        <a:blipFill dpi="0" rotWithShape="1">
+          <a:blip r:embed="rId1">
+            <a:lum/>
+          </a:blip>
+          <a:srcRect/>
+          <a:stretch>
+            <a:fillRect/>
+          </a:stretch>
+        </a:blipFill>
+        <a:effectLst/>
+      </p:bgPr>
+    </p:bg>
+    <p:spTree>
+      <p:nvGrpSpPr>
+        <p:cNvPr id="1" name=""/>
+        <p:cNvGrpSpPr/>
+        <p:nvPr/>
+      </p:nvGrpSpPr>
+      <p:grpSpPr>
+        <a:xfrm>
+          <a:off x="0" y="0"/>
+          <a:ext cx="0" cy="0"/>
+          <a:chOff x="0" y="0"/>
+          <a:chExt cx="0" cy="0"/>
+        </a:xfrm>
+      </p:grpSpPr>
+    </p:spTree>
+  </p:cSld>
+  <p:clrMapOvr>
+    <a:masterClrMapping/>
+  </p:clrMapOvr>
+</p:sld>
+</file>
+
+<file path=ppt/slides/slide25.xml><?xml version="1.0" encoding="utf-8"?>
+<p:sld xmlns:a="http://schemas.openxmlformats.org/drawingml/2006/main" xmlns:r="http://schemas.openxmlformats.org/officeDocument/2006/relationships" xmlns:p="http://schemas.openxmlformats.org/presentationml/2006/main">
+  <p:cSld name="Slide 25">
     <p:bg>
       <p:bgPr>
         <a:blipFill dpi="0" rotWithShape="1">

</xml_diff>